<commit_message>
Fix per-company slide overflow (cap tool rows, clamp footnote)
https://claude.ai/code/session_01VQfoZP2Z81okncaqQv27To
</commit_message>
<xml_diff>
--- a/research_output/agentic_tools_report.pptx
+++ b/research_output/agentic_tools_report.pptx
@@ -3784,7 +3784,7 @@
         </p:nvGraphicFramePr>
         <p:xfrm>
           <a:off x="502920" y="3429000"/>
-          <a:ext cx="11201400" cy="2852928"/>
+          <a:ext cx="11201400" cy="2432304"/>
         </p:xfrm>
         <a:graphic>
           <a:graphicData uri="http://schemas.openxmlformats.org/drawingml/2006/table">
@@ -4223,77 +4223,6 @@
                   </a:tcPr>
                 </a:tc>
               </a:tr>
-              <a:tr h="420624">
-                <a:tc>
-                  <a:txBody>
-                    <a:bodyPr wrap="square"/>
-                    <a:lstStyle/>
-                    <a:p>
-                      <a:pPr algn="l"/>
-                      <a:r>
-                        <a:rPr sz="1050" b="1">
-                          <a:solidFill>
-                            <a:srgbClr val="1B2A38"/>
-                          </a:solidFill>
-                          <a:latin typeface="Calibri"/>
-                        </a:rPr>
-                        <a:t>Antigravity</a:t>
-                      </a:r>
-                    </a:p>
-                  </a:txBody>
-                  <a:tcPr anchor="ctr" marL="76200" marR="76200" marT="25400" marB="25400">
-                    <a:solidFill>
-                      <a:srgbClr val="E7EDF3"/>
-                    </a:solidFill>
-                  </a:tcPr>
-                </a:tc>
-                <a:tc>
-                  <a:txBody>
-                    <a:bodyPr wrap="square"/>
-                    <a:lstStyle/>
-                    <a:p>
-                      <a:pPr algn="ctr"/>
-                      <a:r>
-                        <a:rPr sz="1050" b="1">
-                          <a:solidFill>
-                            <a:srgbClr val="FFFFFF"/>
-                          </a:solidFill>
-                          <a:latin typeface="Calibri"/>
-                        </a:rPr>
-                        <a:t>T4 · none</a:t>
-                      </a:r>
-                    </a:p>
-                  </a:txBody>
-                  <a:tcPr anchor="ctr" marL="76200" marR="76200" marT="25400" marB="25400">
-                    <a:solidFill>
-                      <a:srgbClr val="9E9E9E"/>
-                    </a:solidFill>
-                  </a:tcPr>
-                </a:tc>
-                <a:tc>
-                  <a:txBody>
-                    <a:bodyPr wrap="square"/>
-                    <a:lstStyle/>
-                    <a:p>
-                      <a:pPr algn="l"/>
-                      <a:r>
-                        <a:rPr sz="1000" b="0">
-                          <a:solidFill>
-                            <a:srgbClr val="1B2A38"/>
-                          </a:solidFill>
-                          <a:latin typeface="Calibri"/>
-                        </a:rPr>
-                        <a:t>Builds it · Product</a:t>
-                      </a:r>
-                    </a:p>
-                  </a:txBody>
-                  <a:tcPr anchor="ctr" marL="76200" marR="76200" marT="25400" marB="25400">
-                    <a:solidFill>
-                      <a:srgbClr val="E7EDF3"/>
-                    </a:solidFill>
-                  </a:tcPr>
-                </a:tc>
-              </a:tr>
             </a:tbl>
           </a:graphicData>
         </a:graphic>
@@ -4306,8 +4235,8 @@
         </p:nvSpPr>
         <p:spPr>
           <a:xfrm>
-            <a:off x="502920" y="6391656"/>
-            <a:ext cx="11155680" cy="822960"/>
+            <a:off x="502920" y="5971032"/>
+            <a:ext cx="11155680" cy="457200"/>
           </a:xfrm>
           <a:prstGeom prst="rect">
             <a:avLst/>
@@ -4332,7 +4261,7 @@
                 </a:solidFill>
                 <a:latin typeface="Calibri"/>
               </a:rPr>
-              <a:t>Not confirmed / no evidence: Internal Google engineer use of third-party agentic tools (GitHub Copilot, Cursor, Claude Code, Codex) - reporting indicates the OPPOSITE (restricted); Internal dogfooding of Gemini CLI / Antigravity / Jules / Gemini Code Assist specifically (these are vendor_maker signals, internal use not separately evidenced)   (+2 more tool signal(s) on file)</a:t>
+              <a:t>Not confirmed / no evidence: Internal Google engineer use of third-party agentic tools (GitHub Copilot, Cursor, Claude Code, Codex) - reporting indicates the OPPOSITE (restricted); Internal dogfooding of Gemini CLI / Antigravity / Jules / Gemini Code Assist specifically (these are vendor_maker signals, internal use not separately evidenced)   (+3 more tool signal(s) on file)</a:t>
             </a:r>
           </a:p>
         </p:txBody>
@@ -5020,7 +4949,7 @@
         <p:spPr>
           <a:xfrm>
             <a:off x="502920" y="4709160"/>
-            <a:ext cx="11155680" cy="822960"/>
+            <a:ext cx="11155680" cy="457200"/>
           </a:xfrm>
           <a:prstGeom prst="rect">
             <a:avLst/>
@@ -5875,7 +5804,7 @@
         <p:spPr>
           <a:xfrm>
             <a:off x="502920" y="5550408"/>
-            <a:ext cx="11155680" cy="822960"/>
+            <a:ext cx="11155680" cy="457200"/>
           </a:xfrm>
           <a:prstGeom prst="rect">
             <a:avLst/>
@@ -6659,7 +6588,7 @@
         <p:spPr>
           <a:xfrm>
             <a:off x="502920" y="5129784"/>
-            <a:ext cx="11155680" cy="822960"/>
+            <a:ext cx="11155680" cy="457200"/>
           </a:xfrm>
           <a:prstGeom prst="rect">
             <a:avLst/>
@@ -13488,7 +13417,7 @@
         <p:spPr>
           <a:xfrm>
             <a:off x="502920" y="5550408"/>
-            <a:ext cx="11155680" cy="822960"/>
+            <a:ext cx="11155680" cy="457200"/>
           </a:xfrm>
           <a:prstGeom prst="rect">
             <a:avLst/>
@@ -14272,7 +14201,7 @@
         <p:spPr>
           <a:xfrm>
             <a:off x="502920" y="5129784"/>
-            <a:ext cx="11155680" cy="822960"/>
+            <a:ext cx="11155680" cy="457200"/>
           </a:xfrm>
           <a:prstGeom prst="rect">
             <a:avLst/>
@@ -15056,7 +14985,7 @@
         <p:spPr>
           <a:xfrm>
             <a:off x="502920" y="5129784"/>
-            <a:ext cx="11155680" cy="822960"/>
+            <a:ext cx="11155680" cy="457200"/>
           </a:xfrm>
           <a:prstGeom prst="rect">
             <a:avLst/>
@@ -15769,7 +15698,7 @@
         <p:spPr>
           <a:xfrm>
             <a:off x="502920" y="4709160"/>
-            <a:ext cx="11155680" cy="822960"/>
+            <a:ext cx="11155680" cy="457200"/>
           </a:xfrm>
           <a:prstGeom prst="rect">
             <a:avLst/>
@@ -16553,7 +16482,7 @@
         <p:spPr>
           <a:xfrm>
             <a:off x="502920" y="5129784"/>
-            <a:ext cx="11155680" cy="822960"/>
+            <a:ext cx="11155680" cy="457200"/>
           </a:xfrm>
           <a:prstGeom prst="rect">
             <a:avLst/>
@@ -17408,7 +17337,7 @@
         <p:spPr>
           <a:xfrm>
             <a:off x="502920" y="5550408"/>
-            <a:ext cx="11155680" cy="822960"/>
+            <a:ext cx="11155680" cy="457200"/>
           </a:xfrm>
           <a:prstGeom prst="rect">
             <a:avLst/>

</xml_diff>